<commit_message>
CAMBIOS DEL DIA 3-06-2021
</commit_message>
<xml_diff>
--- a/Scripts_R100_Materiales/Estatus de Mesa/Docs/IT_DEV_SEGUIMIENTO_ORDEN_MESA.pptx
+++ b/Scripts_R100_Materiales/Estatus de Mesa/Docs/IT_DEV_SEGUIMIENTO_ORDEN_MESA.pptx
@@ -209,7 +209,7 @@
           <a:p>
             <a:fld id="{A17B1792-3256-4E77-8442-3E205CD69EF5}" type="datetimeFigureOut">
               <a:rPr lang="en-US" smtClean="0"/>
-              <a:t>5/24/2021</a:t>
+              <a:t>6/3/2021</a:t>
             </a:fld>
             <a:endParaRPr lang="en-US"/>
           </a:p>
@@ -655,7 +655,7 @@
           <a:p>
             <a:fld id="{07558649-2619-44F9-8F30-2D6466E57529}" type="datetimeFigureOut">
               <a:rPr lang="en-US" smtClean="0"/>
-              <a:t>5/24/2021</a:t>
+              <a:t>6/3/2021</a:t>
             </a:fld>
             <a:endParaRPr lang="en-US"/>
           </a:p>
@@ -823,7 +823,7 @@
           <a:p>
             <a:fld id="{07558649-2619-44F9-8F30-2D6466E57529}" type="datetimeFigureOut">
               <a:rPr lang="en-US" smtClean="0"/>
-              <a:t>5/24/2021</a:t>
+              <a:t>6/3/2021</a:t>
             </a:fld>
             <a:endParaRPr lang="en-US"/>
           </a:p>
@@ -1001,7 +1001,7 @@
           <a:p>
             <a:fld id="{07558649-2619-44F9-8F30-2D6466E57529}" type="datetimeFigureOut">
               <a:rPr lang="en-US" smtClean="0"/>
-              <a:t>5/24/2021</a:t>
+              <a:t>6/3/2021</a:t>
             </a:fld>
             <a:endParaRPr lang="en-US"/>
           </a:p>
@@ -1169,7 +1169,7 @@
           <a:p>
             <a:fld id="{07558649-2619-44F9-8F30-2D6466E57529}" type="datetimeFigureOut">
               <a:rPr lang="en-US" smtClean="0"/>
-              <a:t>5/24/2021</a:t>
+              <a:t>6/3/2021</a:t>
             </a:fld>
             <a:endParaRPr lang="en-US"/>
           </a:p>
@@ -1414,7 +1414,7 @@
           <a:p>
             <a:fld id="{07558649-2619-44F9-8F30-2D6466E57529}" type="datetimeFigureOut">
               <a:rPr lang="en-US" smtClean="0"/>
-              <a:t>5/24/2021</a:t>
+              <a:t>6/3/2021</a:t>
             </a:fld>
             <a:endParaRPr lang="en-US"/>
           </a:p>
@@ -1699,7 +1699,7 @@
           <a:p>
             <a:fld id="{07558649-2619-44F9-8F30-2D6466E57529}" type="datetimeFigureOut">
               <a:rPr lang="en-US" smtClean="0"/>
-              <a:t>5/24/2021</a:t>
+              <a:t>6/3/2021</a:t>
             </a:fld>
             <a:endParaRPr lang="en-US"/>
           </a:p>
@@ -2118,7 +2118,7 @@
           <a:p>
             <a:fld id="{07558649-2619-44F9-8F30-2D6466E57529}" type="datetimeFigureOut">
               <a:rPr lang="en-US" smtClean="0"/>
-              <a:t>5/24/2021</a:t>
+              <a:t>6/3/2021</a:t>
             </a:fld>
             <a:endParaRPr lang="en-US"/>
           </a:p>
@@ -2235,7 +2235,7 @@
           <a:p>
             <a:fld id="{07558649-2619-44F9-8F30-2D6466E57529}" type="datetimeFigureOut">
               <a:rPr lang="en-US" smtClean="0"/>
-              <a:t>5/24/2021</a:t>
+              <a:t>6/3/2021</a:t>
             </a:fld>
             <a:endParaRPr lang="en-US"/>
           </a:p>
@@ -2330,7 +2330,7 @@
           <a:p>
             <a:fld id="{07558649-2619-44F9-8F30-2D6466E57529}" type="datetimeFigureOut">
               <a:rPr lang="en-US" smtClean="0"/>
-              <a:t>5/24/2021</a:t>
+              <a:t>6/3/2021</a:t>
             </a:fld>
             <a:endParaRPr lang="en-US"/>
           </a:p>
@@ -2605,7 +2605,7 @@
           <a:p>
             <a:fld id="{07558649-2619-44F9-8F30-2D6466E57529}" type="datetimeFigureOut">
               <a:rPr lang="en-US" smtClean="0"/>
-              <a:t>5/24/2021</a:t>
+              <a:t>6/3/2021</a:t>
             </a:fld>
             <a:endParaRPr lang="en-US"/>
           </a:p>
@@ -2857,7 +2857,7 @@
           <a:p>
             <a:fld id="{07558649-2619-44F9-8F30-2D6466E57529}" type="datetimeFigureOut">
               <a:rPr lang="en-US" smtClean="0"/>
-              <a:t>5/24/2021</a:t>
+              <a:t>6/3/2021</a:t>
             </a:fld>
             <a:endParaRPr lang="en-US"/>
           </a:p>
@@ -3077,7 +3077,7 @@
           <a:p>
             <a:fld id="{07558649-2619-44F9-8F30-2D6466E57529}" type="datetimeFigureOut">
               <a:rPr lang="en-US" smtClean="0"/>
-              <a:t>5/24/2021</a:t>
+              <a:t>6/3/2021</a:t>
             </a:fld>
             <a:endParaRPr lang="en-US"/>
           </a:p>
@@ -3532,6 +3532,42 @@
           <a:chExt cx="0" cy="0"/>
         </a:xfrm>
       </p:grpSpPr>
+      <p:pic>
+        <p:nvPicPr>
+          <p:cNvPr id="14" name="Imagen 13" descr="Tabla&#10;&#10;Descripción generada automáticamente">
+            <a:extLst>
+              <a:ext uri="{FF2B5EF4-FFF2-40B4-BE49-F238E27FC236}">
+                <a16:creationId xmlns:a16="http://schemas.microsoft.com/office/drawing/2014/main" id="{80F1DE32-1288-4DE9-8698-391401136C09}"/>
+              </a:ext>
+            </a:extLst>
+          </p:cNvPr>
+          <p:cNvPicPr>
+            <a:picLocks noChangeAspect="1"/>
+          </p:cNvPicPr>
+          <p:nvPr/>
+        </p:nvPicPr>
+        <p:blipFill>
+          <a:blip r:embed="rId2">
+            <a:extLst>
+              <a:ext uri="{28A0092B-C50C-407E-A947-70E740481C1C}">
+                <a14:useLocalDpi xmlns:a14="http://schemas.microsoft.com/office/drawing/2010/main" val="0"/>
+              </a:ext>
+            </a:extLst>
+          </a:blip>
+          <a:stretch>
+            <a:fillRect/>
+          </a:stretch>
+        </p:blipFill>
+        <p:spPr>
+          <a:xfrm>
+            <a:off x="1127760" y="976024"/>
+            <a:ext cx="7980744" cy="5837351"/>
+          </a:xfrm>
+          <a:prstGeom prst="rect">
+            <a:avLst/>
+          </a:prstGeom>
+        </p:spPr>
+      </p:pic>
       <p:sp>
         <p:nvSpPr>
           <p:cNvPr id="8" name="Title 1"/>
@@ -3754,149 +3790,6 @@
       </p:sp>
       <p:sp>
         <p:nvSpPr>
-          <p:cNvPr id="10" name="Rectangle 9"/>
-          <p:cNvSpPr/>
-          <p:nvPr/>
-        </p:nvSpPr>
-        <p:spPr>
-          <a:xfrm>
-            <a:off x="1115615" y="1054477"/>
-            <a:ext cx="7920879" cy="1015663"/>
-          </a:xfrm>
-          <a:prstGeom prst="rect">
-            <a:avLst/>
-          </a:prstGeom>
-        </p:spPr>
-        <p:txBody>
-          <a:bodyPr wrap="square">
-            <a:spAutoFit/>
-          </a:bodyPr>
-          <a:lstStyle/>
-          <a:p>
-            <a:pPr>
-              <a:buFont typeface="Arial" panose="020B0604020202020204" pitchFamily="34" charset="0"/>
-              <a:buChar char="•"/>
-            </a:pPr>
-            <a:r>
-              <a:rPr lang="es-ES" sz="1200" dirty="0">
-                <a:solidFill>
-                  <a:srgbClr val="222222"/>
-                </a:solidFill>
-                <a:latin typeface="Segoe UI" panose="020B0502040204020203" pitchFamily="34" charset="0"/>
-              </a:rPr>
-              <a:t>Se creo pantalla para estar monitoreando las ordenes abiertas de las diferentes mesas de producción esto con la finalidad de poder anticiparnos en el surtido de piel, los códigos de colores que aparecerán en el listado son </a:t>
-            </a:r>
-            <a:r>
-              <a:rPr lang="es-ES" sz="1200" b="1" dirty="0">
-                <a:solidFill>
-                  <a:srgbClr val="222222"/>
-                </a:solidFill>
-                <a:latin typeface="Segoe UI" panose="020B0502040204020203" pitchFamily="34" charset="0"/>
-              </a:rPr>
-              <a:t>Rojo</a:t>
-            </a:r>
-            <a:r>
-              <a:rPr lang="es-ES" sz="1200" dirty="0">
-                <a:solidFill>
-                  <a:srgbClr val="222222"/>
-                </a:solidFill>
-                <a:latin typeface="Segoe UI" panose="020B0502040204020203" pitchFamily="34" charset="0"/>
-              </a:rPr>
-              <a:t> (Cuando las pieles pendientes de cortar en la orden sea entre 0-2 y que el numero de patrones no se completen aun), </a:t>
-            </a:r>
-            <a:r>
-              <a:rPr lang="es-ES" sz="1200" b="1" dirty="0">
-                <a:solidFill>
-                  <a:srgbClr val="222222"/>
-                </a:solidFill>
-                <a:latin typeface="Segoe UI" panose="020B0502040204020203" pitchFamily="34" charset="0"/>
-              </a:rPr>
-              <a:t>Amarillo</a:t>
-            </a:r>
-            <a:r>
-              <a:rPr lang="es-ES" sz="1200" dirty="0">
-                <a:solidFill>
-                  <a:srgbClr val="222222"/>
-                </a:solidFill>
-                <a:latin typeface="Segoe UI" panose="020B0502040204020203" pitchFamily="34" charset="0"/>
-              </a:rPr>
-              <a:t> (Cuando las pieles pendientes de cortar en la orden sea entre 3-5 y que el numero de patrones no se completen aun) y </a:t>
-            </a:r>
-            <a:r>
-              <a:rPr lang="es-ES" sz="1200" b="1" dirty="0">
-                <a:solidFill>
-                  <a:srgbClr val="222222"/>
-                </a:solidFill>
-                <a:latin typeface="Segoe UI" panose="020B0502040204020203" pitchFamily="34" charset="0"/>
-              </a:rPr>
-              <a:t>verde</a:t>
-            </a:r>
-            <a:r>
-              <a:rPr lang="es-ES" sz="1200" dirty="0">
-                <a:solidFill>
-                  <a:srgbClr val="222222"/>
-                </a:solidFill>
-                <a:latin typeface="Segoe UI" panose="020B0502040204020203" pitchFamily="34" charset="0"/>
-              </a:rPr>
-              <a:t> (Cuando el numero de patrones estén </a:t>
-            </a:r>
-            <a:r>
-              <a:rPr lang="es-ES" sz="1200">
-                <a:solidFill>
-                  <a:srgbClr val="222222"/>
-                </a:solidFill>
-                <a:latin typeface="Segoe UI" panose="020B0502040204020203" pitchFamily="34" charset="0"/>
-              </a:rPr>
-              <a:t>completos).</a:t>
-            </a:r>
-            <a:endParaRPr lang="es-ES" sz="1200" i="0" dirty="0">
-              <a:solidFill>
-                <a:srgbClr val="222222"/>
-              </a:solidFill>
-              <a:effectLst/>
-              <a:latin typeface="Segoe UI" panose="020B0502040204020203" pitchFamily="34" charset="0"/>
-            </a:endParaRPr>
-          </a:p>
-        </p:txBody>
-      </p:sp>
-      <p:pic>
-        <p:nvPicPr>
-          <p:cNvPr id="5" name="Imagen 4" descr="Interfaz de usuario gráfica, Tabla, Excel&#10;&#10;Descripción generada automáticamente">
-            <a:extLst>
-              <a:ext uri="{FF2B5EF4-FFF2-40B4-BE49-F238E27FC236}">
-                <a16:creationId xmlns:a16="http://schemas.microsoft.com/office/drawing/2014/main" id="{07FB1721-A40B-4FB7-8EB1-1698EB10B276}"/>
-              </a:ext>
-            </a:extLst>
-          </p:cNvPr>
-          <p:cNvPicPr>
-            <a:picLocks noChangeAspect="1"/>
-          </p:cNvPicPr>
-          <p:nvPr/>
-        </p:nvPicPr>
-        <p:blipFill>
-          <a:blip r:embed="rId2">
-            <a:extLst>
-              <a:ext uri="{28A0092B-C50C-407E-A947-70E740481C1C}">
-                <a14:useLocalDpi xmlns:a14="http://schemas.microsoft.com/office/drawing/2010/main" val="0"/>
-              </a:ext>
-            </a:extLst>
-          </a:blip>
-          <a:stretch>
-            <a:fillRect/>
-          </a:stretch>
-        </p:blipFill>
-        <p:spPr>
-          <a:xfrm>
-            <a:off x="1115614" y="2060848"/>
-            <a:ext cx="8028385" cy="4680520"/>
-          </a:xfrm>
-          <a:prstGeom prst="rect">
-            <a:avLst/>
-          </a:prstGeom>
-        </p:spPr>
-      </p:pic>
-      <p:sp>
-        <p:nvSpPr>
           <p:cNvPr id="6" name="Rectángulo 5">
             <a:extLst>
               <a:ext uri="{FF2B5EF4-FFF2-40B4-BE49-F238E27FC236}">
@@ -3909,8 +3802,8 @@
         </p:nvSpPr>
         <p:spPr>
           <a:xfrm>
-            <a:off x="5364088" y="2276872"/>
-            <a:ext cx="2664296" cy="2952328"/>
+            <a:off x="5407488" y="1268760"/>
+            <a:ext cx="2608752" cy="5400600"/>
           </a:xfrm>
           <a:prstGeom prst="rect">
             <a:avLst/>

</xml_diff>